<commit_message>
Add week-10/11 materials, week09 grading, untrack credential file
- Week 10: homework spec for agentic workflows + slide refresh
- Week 11: Streamlit lecture refresh, demo scripts (demo01-14), full
  cognitive-aging app with 3-step practice scaffold, slides v2
- Week 09: grading config + feedback PDF compile script
- eeclass_grader.py: standalone grader script (was previously
  documented in homeworks/CLAUDE.md only)
- Untrack homeworks/CLAUDE.md (contained instructor credentials and
  student PII); add to .gitignore alongside student feedback HTML/CSS,
  debug/dry-run screenshots, and Office lock files

Co-Authored-By: Claude Opus 4.7 (1M context) <noreply@anthropic.com>
</commit_message>
<xml_diff>
--- a/week-10-agentic_workflows_and_github/week-10-slides.pptx
+++ b/week-10-agentic_workflows_and_github/week-10-slides.pptx
@@ -3439,6 +3439,18 @@
   <p:clrMapOvr>
     <a:masterClrMapping/>
   </p:clrMapOvr>
+  <mc:AlternateContent xmlns:mc="http://schemas.openxmlformats.org/markup-compatibility/2006" xmlns:p14="http://schemas.microsoft.com/office/powerpoint/2010/main">
+    <mc:Choice Requires="p14">
+      <p:transition spd="slow" p14:dur="2000">
+        <p:cut/>
+      </p:transition>
+    </mc:Choice>
+    <mc:Fallback xmlns="">
+      <p:transition spd="slow">
+        <p:cut/>
+      </p:transition>
+    </mc:Fallback>
+  </mc:AlternateContent>
 </p:sld>
 </file>
 
@@ -3913,6 +3925,18 @@
   <p:clrMapOvr>
     <a:masterClrMapping/>
   </p:clrMapOvr>
+  <mc:AlternateContent xmlns:mc="http://schemas.openxmlformats.org/markup-compatibility/2006" xmlns:p14="http://schemas.microsoft.com/office/powerpoint/2010/main">
+    <mc:Choice Requires="p14">
+      <p:transition spd="slow" p14:dur="2000">
+        <p:cut/>
+      </p:transition>
+    </mc:Choice>
+    <mc:Fallback xmlns="">
+      <p:transition spd="slow">
+        <p:cut/>
+      </p:transition>
+    </mc:Fallback>
+  </mc:AlternateContent>
 </p:sld>
 </file>
 
@@ -4646,6 +4670,18 @@
   <p:clrMapOvr>
     <a:masterClrMapping/>
   </p:clrMapOvr>
+  <mc:AlternateContent xmlns:mc="http://schemas.openxmlformats.org/markup-compatibility/2006" xmlns:p14="http://schemas.microsoft.com/office/powerpoint/2010/main">
+    <mc:Choice Requires="p14">
+      <p:transition spd="slow" p14:dur="2000">
+        <p:cut/>
+      </p:transition>
+    </mc:Choice>
+    <mc:Fallback xmlns="">
+      <p:transition spd="slow">
+        <p:cut/>
+      </p:transition>
+    </mc:Fallback>
+  </mc:AlternateContent>
 </p:sld>
 </file>
 
@@ -5249,6 +5285,18 @@
   <p:clrMapOvr>
     <a:masterClrMapping/>
   </p:clrMapOvr>
+  <mc:AlternateContent xmlns:mc="http://schemas.openxmlformats.org/markup-compatibility/2006" xmlns:p14="http://schemas.microsoft.com/office/powerpoint/2010/main">
+    <mc:Choice Requires="p14">
+      <p:transition spd="slow" p14:dur="2000">
+        <p:cut/>
+      </p:transition>
+    </mc:Choice>
+    <mc:Fallback xmlns="">
+      <p:transition spd="slow">
+        <p:cut/>
+      </p:transition>
+    </mc:Fallback>
+  </mc:AlternateContent>
 </p:sld>
 </file>
 
@@ -5377,6 +5425,18 @@
   <p:clrMapOvr>
     <a:masterClrMapping/>
   </p:clrMapOvr>
+  <mc:AlternateContent xmlns:mc="http://schemas.openxmlformats.org/markup-compatibility/2006" xmlns:p14="http://schemas.microsoft.com/office/powerpoint/2010/main">
+    <mc:Choice Requires="p14">
+      <p:transition spd="slow" p14:dur="2000">
+        <p:cut/>
+      </p:transition>
+    </mc:Choice>
+    <mc:Fallback xmlns="">
+      <p:transition spd="slow">
+        <p:cut/>
+      </p:transition>
+    </mc:Fallback>
+  </mc:AlternateContent>
 </p:sld>
 </file>
 
@@ -5505,6 +5565,18 @@
   <p:clrMapOvr>
     <a:masterClrMapping/>
   </p:clrMapOvr>
+  <mc:AlternateContent xmlns:mc="http://schemas.openxmlformats.org/markup-compatibility/2006" xmlns:p14="http://schemas.microsoft.com/office/powerpoint/2010/main">
+    <mc:Choice Requires="p14">
+      <p:transition spd="slow" p14:dur="2000">
+        <p:cut/>
+      </p:transition>
+    </mc:Choice>
+    <mc:Fallback xmlns="">
+      <p:transition spd="slow">
+        <p:cut/>
+      </p:transition>
+    </mc:Fallback>
+  </mc:AlternateContent>
 </p:sld>
 </file>
 
@@ -5633,6 +5705,18 @@
   <p:clrMapOvr>
     <a:masterClrMapping/>
   </p:clrMapOvr>
+  <mc:AlternateContent xmlns:mc="http://schemas.openxmlformats.org/markup-compatibility/2006" xmlns:p14="http://schemas.microsoft.com/office/powerpoint/2010/main">
+    <mc:Choice Requires="p14">
+      <p:transition spd="slow" p14:dur="2000">
+        <p:cut/>
+      </p:transition>
+    </mc:Choice>
+    <mc:Fallback xmlns="">
+      <p:transition spd="slow">
+        <p:cut/>
+      </p:transition>
+    </mc:Fallback>
+  </mc:AlternateContent>
 </p:sld>
 </file>
 
@@ -5819,8 +5903,8 @@
         </p:nvSpPr>
         <p:spPr>
           <a:xfrm>
-            <a:off x="640080" y="1874519"/>
-            <a:ext cx="10881360" cy="4206240"/>
+            <a:off x="579120" y="1499615"/>
+            <a:ext cx="10881360" cy="4946905"/>
           </a:xfrm>
           <a:prstGeom prst="roundRect">
             <a:avLst>
@@ -6313,13 +6397,6 @@
               </a:rPr>
               <a:t> </a:t>
             </a:r>
-          </a:p>
-          <a:p>
-            <a:pPr algn="l">
-              <a:lnSpc>
-                <a:spcPct val="110000"/>
-              </a:lnSpc>
-            </a:pPr>
             <a:r>
               <a:rPr sz="2000" dirty="0">
                 <a:solidFill>
@@ -6386,7 +6463,7 @@
         </p:nvSpPr>
         <p:spPr>
           <a:xfrm>
-            <a:off x="640080" y="6126480"/>
+            <a:off x="4114800" y="6492240"/>
             <a:ext cx="10972800" cy="365760"/>
           </a:xfrm>
           <a:prstGeom prst="rect">
@@ -6402,14 +6479,65 @@
           <a:p>
             <a:pPr algn="l"/>
             <a:r>
-              <a:rPr sz="1800" b="0">
+              <a:rPr sz="1800" b="0" dirty="0">
                 <a:solidFill>
                   <a:srgbClr val="FFB700"/>
                 </a:solidFill>
                 <a:latin typeface="Microsoft JhengHei"/>
               </a:rPr>
-              <a:t>.venv/ 永遠不入 git — 它太大，而且每個人的系統會自己重建</a:t>
-            </a:r>
+              <a:t>.</a:t>
+            </a:r>
+            <a:r>
+              <a:rPr sz="1800" b="0" dirty="0" err="1">
+                <a:solidFill>
+                  <a:srgbClr val="FFB700"/>
+                </a:solidFill>
+                <a:latin typeface="Microsoft JhengHei"/>
+              </a:rPr>
+              <a:t>venv</a:t>
+            </a:r>
+            <a:r>
+              <a:rPr sz="1800" b="0" dirty="0">
+                <a:solidFill>
+                  <a:srgbClr val="FFB700"/>
+                </a:solidFill>
+                <a:latin typeface="Microsoft JhengHei"/>
+              </a:rPr>
+              <a:t>/ </a:t>
+            </a:r>
+            <a:r>
+              <a:rPr sz="1800" b="0" dirty="0" err="1">
+                <a:solidFill>
+                  <a:srgbClr val="FFB700"/>
+                </a:solidFill>
+                <a:latin typeface="Microsoft JhengHei"/>
+              </a:rPr>
+              <a:t>永遠不入</a:t>
+            </a:r>
+            <a:r>
+              <a:rPr sz="1800" b="0" dirty="0">
+                <a:solidFill>
+                  <a:srgbClr val="FFB700"/>
+                </a:solidFill>
+                <a:latin typeface="Microsoft JhengHei"/>
+              </a:rPr>
+              <a:t> git — </a:t>
+            </a:r>
+            <a:r>
+              <a:rPr sz="1800" b="0" dirty="0" err="1">
+                <a:solidFill>
+                  <a:srgbClr val="FFB700"/>
+                </a:solidFill>
+                <a:latin typeface="Microsoft JhengHei"/>
+              </a:rPr>
+              <a:t>它太大，而且每個人的系統會自己重建</a:t>
+            </a:r>
+            <a:endParaRPr sz="1800" b="0" dirty="0">
+              <a:solidFill>
+                <a:srgbClr val="FFB700"/>
+              </a:solidFill>
+              <a:latin typeface="Microsoft JhengHei"/>
+            </a:endParaRPr>
           </a:p>
         </p:txBody>
       </p:sp>
@@ -6488,6 +6616,18 @@
   <p:clrMapOvr>
     <a:masterClrMapping/>
   </p:clrMapOvr>
+  <mc:AlternateContent xmlns:mc="http://schemas.openxmlformats.org/markup-compatibility/2006" xmlns:p14="http://schemas.microsoft.com/office/powerpoint/2010/main">
+    <mc:Choice Requires="p14">
+      <p:transition spd="slow" p14:dur="2000">
+        <p:cut/>
+      </p:transition>
+    </mc:Choice>
+    <mc:Fallback xmlns="">
+      <p:transition spd="slow">
+        <p:cut/>
+      </p:transition>
+    </mc:Fallback>
+  </mc:AlternateContent>
 </p:sld>
 </file>
 
@@ -7056,6 +7196,18 @@
   <p:clrMapOvr>
     <a:masterClrMapping/>
   </p:clrMapOvr>
+  <mc:AlternateContent xmlns:mc="http://schemas.openxmlformats.org/markup-compatibility/2006" xmlns:p14="http://schemas.microsoft.com/office/powerpoint/2010/main">
+    <mc:Choice Requires="p14">
+      <p:transition spd="slow" p14:dur="2000">
+        <p:cut/>
+      </p:transition>
+    </mc:Choice>
+    <mc:Fallback xmlns="">
+      <p:transition spd="slow">
+        <p:cut/>
+      </p:transition>
+    </mc:Fallback>
+  </mc:AlternateContent>
 </p:sld>
 </file>
 
@@ -7184,6 +7336,18 @@
   <p:clrMapOvr>
     <a:masterClrMapping/>
   </p:clrMapOvr>
+  <mc:AlternateContent xmlns:mc="http://schemas.openxmlformats.org/markup-compatibility/2006" xmlns:p14="http://schemas.microsoft.com/office/powerpoint/2010/main">
+    <mc:Choice Requires="p14">
+      <p:transition spd="slow" p14:dur="2000">
+        <p:cut/>
+      </p:transition>
+    </mc:Choice>
+    <mc:Fallback xmlns="">
+      <p:transition spd="slow">
+        <p:cut/>
+      </p:transition>
+    </mc:Fallback>
+  </mc:AlternateContent>
 </p:sld>
 </file>
 
@@ -7428,6 +7592,18 @@
   <p:clrMapOvr>
     <a:masterClrMapping/>
   </p:clrMapOvr>
+  <mc:AlternateContent xmlns:mc="http://schemas.openxmlformats.org/markup-compatibility/2006" xmlns:p14="http://schemas.microsoft.com/office/powerpoint/2010/main">
+    <mc:Choice Requires="p14">
+      <p:transition spd="slow" p14:dur="2000">
+        <p:cut/>
+      </p:transition>
+    </mc:Choice>
+    <mc:Fallback xmlns="">
+      <p:transition spd="slow">
+        <p:cut/>
+      </p:transition>
+    </mc:Fallback>
+  </mc:AlternateContent>
 </p:sld>
 </file>
 
@@ -8037,6 +8213,18 @@
   <p:clrMapOvr>
     <a:masterClrMapping/>
   </p:clrMapOvr>
+  <mc:AlternateContent xmlns:mc="http://schemas.openxmlformats.org/markup-compatibility/2006" xmlns:p14="http://schemas.microsoft.com/office/powerpoint/2010/main">
+    <mc:Choice Requires="p14">
+      <p:transition spd="slow" p14:dur="2000">
+        <p:cut/>
+      </p:transition>
+    </mc:Choice>
+    <mc:Fallback xmlns="">
+      <p:transition spd="slow">
+        <p:cut/>
+      </p:transition>
+    </mc:Fallback>
+  </mc:AlternateContent>
 </p:sld>
 </file>
 
@@ -8694,6 +8882,18 @@
   <p:clrMapOvr>
     <a:masterClrMapping/>
   </p:clrMapOvr>
+  <mc:AlternateContent xmlns:mc="http://schemas.openxmlformats.org/markup-compatibility/2006" xmlns:p14="http://schemas.microsoft.com/office/powerpoint/2010/main">
+    <mc:Choice Requires="p14">
+      <p:transition spd="slow" p14:dur="2000">
+        <p:cut/>
+      </p:transition>
+    </mc:Choice>
+    <mc:Fallback xmlns="">
+      <p:transition spd="slow">
+        <p:cut/>
+      </p:transition>
+    </mc:Fallback>
+  </mc:AlternateContent>
 </p:sld>
 </file>
 
@@ -9443,6 +9643,18 @@
   <p:clrMapOvr>
     <a:masterClrMapping/>
   </p:clrMapOvr>
+  <mc:AlternateContent xmlns:mc="http://schemas.openxmlformats.org/markup-compatibility/2006" xmlns:p14="http://schemas.microsoft.com/office/powerpoint/2010/main">
+    <mc:Choice Requires="p14">
+      <p:transition spd="slow" p14:dur="2000">
+        <p:cut/>
+      </p:transition>
+    </mc:Choice>
+    <mc:Fallback xmlns="">
+      <p:transition spd="slow">
+        <p:cut/>
+      </p:transition>
+    </mc:Fallback>
+  </mc:AlternateContent>
 </p:sld>
 </file>
 
@@ -9508,6 +9720,18 @@
   <p:clrMapOvr>
     <a:masterClrMapping/>
   </p:clrMapOvr>
+  <mc:AlternateContent xmlns:mc="http://schemas.openxmlformats.org/markup-compatibility/2006" xmlns:p14="http://schemas.microsoft.com/office/powerpoint/2010/main">
+    <mc:Choice Requires="p14">
+      <p:transition spd="slow" p14:dur="2000">
+        <p:cut/>
+      </p:transition>
+    </mc:Choice>
+    <mc:Fallback xmlns="">
+      <p:transition spd="slow">
+        <p:cut/>
+      </p:transition>
+    </mc:Fallback>
+  </mc:AlternateContent>
 </p:sld>
 </file>
 
@@ -10327,6 +10551,18 @@
   <p:clrMapOvr>
     <a:masterClrMapping/>
   </p:clrMapOvr>
+  <mc:AlternateContent xmlns:mc="http://schemas.openxmlformats.org/markup-compatibility/2006" xmlns:p14="http://schemas.microsoft.com/office/powerpoint/2010/main">
+    <mc:Choice Requires="p14">
+      <p:transition spd="slow" p14:dur="2000">
+        <p:cut/>
+      </p:transition>
+    </mc:Choice>
+    <mc:Fallback xmlns="">
+      <p:transition spd="slow">
+        <p:cut/>
+      </p:transition>
+    </mc:Fallback>
+  </mc:AlternateContent>
 </p:sld>
 </file>
 
@@ -11111,6 +11347,18 @@
   <p:clrMapOvr>
     <a:masterClrMapping/>
   </p:clrMapOvr>
+  <mc:AlternateContent xmlns:mc="http://schemas.openxmlformats.org/markup-compatibility/2006" xmlns:p14="http://schemas.microsoft.com/office/powerpoint/2010/main">
+    <mc:Choice Requires="p14">
+      <p:transition spd="slow" p14:dur="2000">
+        <p:cut/>
+      </p:transition>
+    </mc:Choice>
+    <mc:Fallback xmlns="">
+      <p:transition spd="slow">
+        <p:cut/>
+      </p:transition>
+    </mc:Fallback>
+  </mc:AlternateContent>
 </p:sld>
 </file>
 
@@ -11371,7 +11619,7 @@
               </a:lnSpc>
             </a:pPr>
             <a:r>
-              <a:rPr sz="1300">
+              <a:rPr sz="1300" dirty="0">
                 <a:solidFill>
                   <a:srgbClr val="FFB700"/>
                 </a:solidFill>
@@ -11387,7 +11635,7 @@
               </a:lnSpc>
             </a:pPr>
             <a:r>
-              <a:rPr sz="1300">
+              <a:rPr sz="1300" dirty="0">
                 <a:solidFill>
                   <a:srgbClr val="F7F9FB"/>
                 </a:solidFill>
@@ -11403,7 +11651,7 @@
               </a:lnSpc>
             </a:pPr>
             <a:r>
-              <a:rPr sz="1300">
+              <a:rPr sz="1300" dirty="0">
                 <a:solidFill>
                   <a:srgbClr val="F7F9FB"/>
                 </a:solidFill>
@@ -11419,7 +11667,7 @@
               </a:lnSpc>
             </a:pPr>
             <a:r>
-              <a:rPr sz="1300">
+              <a:rPr sz="1300" dirty="0">
                 <a:solidFill>
                   <a:srgbClr val="F7F9FB"/>
                 </a:solidFill>
@@ -11435,13 +11683,67 @@
               </a:lnSpc>
             </a:pPr>
             <a:r>
-              <a:rPr sz="1300">
-                <a:solidFill>
-                  <a:srgbClr val="F7F9FB"/>
-                </a:solidFill>
-                <a:latin typeface="Consolas"/>
-              </a:rPr>
-              <a:t>    - long format: 測站, 日期, 測項, 00..23</a:t>
+              <a:rPr sz="1300" dirty="0">
+                <a:solidFill>
+                  <a:srgbClr val="F7F9FB"/>
+                </a:solidFill>
+                <a:latin typeface="Consolas"/>
+              </a:rPr>
+              <a:t>    - long format: </a:t>
+            </a:r>
+            <a:r>
+              <a:rPr sz="1300" dirty="0" err="1">
+                <a:solidFill>
+                  <a:srgbClr val="F7F9FB"/>
+                </a:solidFill>
+                <a:latin typeface="Consolas"/>
+              </a:rPr>
+              <a:t>測站</a:t>
+            </a:r>
+            <a:r>
+              <a:rPr sz="1300" dirty="0">
+                <a:solidFill>
+                  <a:srgbClr val="F7F9FB"/>
+                </a:solidFill>
+                <a:latin typeface="Consolas"/>
+              </a:rPr>
+              <a:t>, </a:t>
+            </a:r>
+            <a:r>
+              <a:rPr sz="1300" dirty="0" err="1">
+                <a:solidFill>
+                  <a:srgbClr val="F7F9FB"/>
+                </a:solidFill>
+                <a:latin typeface="Consolas"/>
+              </a:rPr>
+              <a:t>日期</a:t>
+            </a:r>
+            <a:r>
+              <a:rPr sz="1300" dirty="0">
+                <a:solidFill>
+                  <a:srgbClr val="F7F9FB"/>
+                </a:solidFill>
+                <a:latin typeface="Consolas"/>
+              </a:rPr>
+              <a:t>, </a:t>
+            </a:r>
+            <a:r>
+              <a:rPr sz="1300" dirty="0" err="1">
+                <a:solidFill>
+                  <a:srgbClr val="F7F9FB"/>
+                </a:solidFill>
+                <a:latin typeface="Consolas"/>
+              </a:rPr>
+              <a:t>測項</a:t>
+            </a:r>
+            <a:r>
+              <a:rPr sz="1300" dirty="0">
+                <a:solidFill>
+                  <a:srgbClr val="F7F9FB"/>
+                </a:solidFill>
+                <a:latin typeface="Consolas"/>
+              </a:rPr>
+              <a:t>, 00..23</a:t>
             </a:r>
           </a:p>
           <a:p>
@@ -11451,7 +11753,7 @@
               </a:lnSpc>
             </a:pPr>
             <a:r>
-              <a:rPr sz="1300">
+              <a:rPr sz="1300" dirty="0">
                 <a:solidFill>
                   <a:srgbClr val="F7F9FB"/>
                 </a:solidFill>
@@ -11467,7 +11769,7 @@
               </a:lnSpc>
             </a:pPr>
             <a:r>
-              <a:rPr sz="1300">
+              <a:rPr sz="1300" dirty="0">
                 <a:solidFill>
                   <a:srgbClr val="F7F9FB"/>
                 </a:solidFill>
@@ -11483,13 +11785,31 @@
               </a:lnSpc>
             </a:pPr>
             <a:r>
-              <a:rPr sz="1300">
-                <a:solidFill>
-                  <a:srgbClr val="F7F9FB"/>
-                </a:solidFill>
-                <a:latin typeface="Consolas"/>
-              </a:rPr>
-              <a:t>    1. Load the 4 CSVs, keep 測項 == 'PM2.5'.</a:t>
+              <a:rPr sz="1300" dirty="0">
+                <a:solidFill>
+                  <a:srgbClr val="F7F9FB"/>
+                </a:solidFill>
+                <a:latin typeface="Consolas"/>
+              </a:rPr>
+              <a:t>    1. Load the 4 CSVs, keep </a:t>
+            </a:r>
+            <a:r>
+              <a:rPr sz="1300" dirty="0" err="1">
+                <a:solidFill>
+                  <a:srgbClr val="F7F9FB"/>
+                </a:solidFill>
+                <a:latin typeface="Consolas"/>
+              </a:rPr>
+              <a:t>測項</a:t>
+            </a:r>
+            <a:r>
+              <a:rPr sz="1300" dirty="0">
+                <a:solidFill>
+                  <a:srgbClr val="F7F9FB"/>
+                </a:solidFill>
+                <a:latin typeface="Consolas"/>
+              </a:rPr>
+              <a:t> == 'PM2.5'.</a:t>
             </a:r>
           </a:p>
           <a:p>
@@ -11499,7 +11819,7 @@
               </a:lnSpc>
             </a:pPr>
             <a:r>
-              <a:rPr sz="1300">
+              <a:rPr sz="1300" dirty="0">
                 <a:solidFill>
                   <a:srgbClr val="F7F9FB"/>
                 </a:solidFill>
@@ -11515,7 +11835,7 @@
               </a:lnSpc>
             </a:pPr>
             <a:r>
-              <a:rPr sz="1300">
+              <a:rPr sz="1300" dirty="0">
                 <a:solidFill>
                   <a:srgbClr val="F7F9FB"/>
                 </a:solidFill>
@@ -11531,7 +11851,7 @@
               </a:lnSpc>
             </a:pPr>
             <a:r>
-              <a:rPr sz="1300">
+              <a:rPr sz="1300" dirty="0">
                 <a:solidFill>
                   <a:srgbClr val="F7F9FB"/>
                 </a:solidFill>
@@ -11547,7 +11867,7 @@
               </a:lnSpc>
             </a:pPr>
             <a:r>
-              <a:rPr sz="1300">
+              <a:rPr sz="1300" dirty="0">
                 <a:solidFill>
                   <a:srgbClr val="F7F9FB"/>
                 </a:solidFill>
@@ -11563,7 +11883,7 @@
               </a:lnSpc>
             </a:pPr>
             <a:r>
-              <a:rPr sz="1300">
+              <a:rPr sz="1300" dirty="0">
                 <a:solidFill>
                   <a:srgbClr val="F7F9FB"/>
                 </a:solidFill>
@@ -11579,7 +11899,7 @@
               </a:lnSpc>
             </a:pPr>
             <a:r>
-              <a:rPr sz="1300">
+              <a:rPr sz="1300" dirty="0">
                 <a:solidFill>
                   <a:srgbClr val="F7F9FB"/>
                 </a:solidFill>
@@ -11595,7 +11915,7 @@
               </a:lnSpc>
             </a:pPr>
             <a:r>
-              <a:rPr sz="1300">
+              <a:rPr sz="1300" dirty="0">
                 <a:solidFill>
                   <a:srgbClr val="F7F9FB"/>
                 </a:solidFill>
@@ -11611,7 +11931,7 @@
               </a:lnSpc>
             </a:pPr>
             <a:r>
-              <a:rPr sz="1300">
+              <a:rPr sz="1300" dirty="0">
                 <a:solidFill>
                   <a:srgbClr val="F7F9FB"/>
                 </a:solidFill>
@@ -11627,7 +11947,7 @@
               </a:lnSpc>
             </a:pPr>
             <a:r>
-              <a:rPr sz="1300">
+              <a:rPr sz="1300" dirty="0">
                 <a:solidFill>
                   <a:srgbClr val="F7F9FB"/>
                 </a:solidFill>
@@ -11643,7 +11963,7 @@
               </a:lnSpc>
             </a:pPr>
             <a:r>
-              <a:rPr sz="1300">
+              <a:rPr sz="1300" dirty="0">
                 <a:solidFill>
                   <a:srgbClr val="F7F9FB"/>
                 </a:solidFill>
@@ -11659,13 +11979,31 @@
               </a:lnSpc>
             </a:pPr>
             <a:r>
-              <a:rPr sz="1300">
-                <a:solidFill>
-                  <a:srgbClr val="F7F9FB"/>
-                </a:solidFill>
-                <a:latin typeface="Consolas"/>
-              </a:rPr>
-              <a:t>    - np.random.seed(42) for any synthetic.</a:t>
+              <a:rPr sz="1300" dirty="0">
+                <a:solidFill>
+                  <a:srgbClr val="F7F9FB"/>
+                </a:solidFill>
+                <a:latin typeface="Consolas"/>
+              </a:rPr>
+              <a:t>    - </a:t>
+            </a:r>
+            <a:r>
+              <a:rPr sz="1300" dirty="0" err="1">
+                <a:solidFill>
+                  <a:srgbClr val="F7F9FB"/>
+                </a:solidFill>
+                <a:latin typeface="Consolas"/>
+              </a:rPr>
+              <a:t>np.random.seed</a:t>
+            </a:r>
+            <a:r>
+              <a:rPr sz="1300" dirty="0">
+                <a:solidFill>
+                  <a:srgbClr val="F7F9FB"/>
+                </a:solidFill>
+                <a:latin typeface="Consolas"/>
+              </a:rPr>
+              <a:t>(42) for any synthetic.</a:t>
             </a:r>
           </a:p>
         </p:txBody>
@@ -11975,6 +12313,18 @@
   <p:clrMapOvr>
     <a:masterClrMapping/>
   </p:clrMapOvr>
+  <mc:AlternateContent xmlns:mc="http://schemas.openxmlformats.org/markup-compatibility/2006" xmlns:p14="http://schemas.microsoft.com/office/powerpoint/2010/main">
+    <mc:Choice Requires="p14">
+      <p:transition spd="slow" p14:dur="2000">
+        <p:cut/>
+      </p:transition>
+    </mc:Choice>
+    <mc:Fallback xmlns="">
+      <p:transition spd="slow">
+        <p:cut/>
+      </p:transition>
+    </mc:Fallback>
+  </mc:AlternateContent>
 </p:sld>
 </file>
 
@@ -12219,6 +12569,18 @@
   <p:clrMapOvr>
     <a:masterClrMapping/>
   </p:clrMapOvr>
+  <mc:AlternateContent xmlns:mc="http://schemas.openxmlformats.org/markup-compatibility/2006" xmlns:p14="http://schemas.microsoft.com/office/powerpoint/2010/main">
+    <mc:Choice Requires="p14">
+      <p:transition spd="slow" p14:dur="2000">
+        <p:cut/>
+      </p:transition>
+    </mc:Choice>
+    <mc:Fallback xmlns="">
+      <p:transition spd="slow">
+        <p:cut/>
+      </p:transition>
+    </mc:Fallback>
+  </mc:AlternateContent>
 </p:sld>
 </file>
 
@@ -12709,6 +13071,18 @@
   <p:clrMapOvr>
     <a:masterClrMapping/>
   </p:clrMapOvr>
+  <mc:AlternateContent xmlns:mc="http://schemas.openxmlformats.org/markup-compatibility/2006" xmlns:p14="http://schemas.microsoft.com/office/powerpoint/2010/main">
+    <mc:Choice Requires="p14">
+      <p:transition spd="slow" p14:dur="2000">
+        <p:cut/>
+      </p:transition>
+    </mc:Choice>
+    <mc:Fallback xmlns="">
+      <p:transition spd="slow">
+        <p:cut/>
+      </p:transition>
+    </mc:Fallback>
+  </mc:AlternateContent>
 </p:sld>
 </file>
 
@@ -13455,6 +13829,18 @@
   <p:clrMapOvr>
     <a:masterClrMapping/>
   </p:clrMapOvr>
+  <mc:AlternateContent xmlns:mc="http://schemas.openxmlformats.org/markup-compatibility/2006" xmlns:p14="http://schemas.microsoft.com/office/powerpoint/2010/main">
+    <mc:Choice Requires="p14">
+      <p:transition spd="slow" p14:dur="2000">
+        <p:cut/>
+      </p:transition>
+    </mc:Choice>
+    <mc:Fallback xmlns="">
+      <p:transition spd="slow">
+        <p:cut/>
+      </p:transition>
+    </mc:Fallback>
+  </mc:AlternateContent>
 </p:sld>
 </file>
 
@@ -13699,6 +14085,18 @@
   <p:clrMapOvr>
     <a:masterClrMapping/>
   </p:clrMapOvr>
+  <mc:AlternateContent xmlns:mc="http://schemas.openxmlformats.org/markup-compatibility/2006" xmlns:p14="http://schemas.microsoft.com/office/powerpoint/2010/main">
+    <mc:Choice Requires="p14">
+      <p:transition spd="slow" p14:dur="2000">
+        <p:cut/>
+      </p:transition>
+    </mc:Choice>
+    <mc:Fallback xmlns="">
+      <p:transition spd="slow">
+        <p:cut/>
+      </p:transition>
+    </mc:Fallback>
+  </mc:AlternateContent>
 </p:sld>
 </file>
 
@@ -13943,6 +14341,18 @@
   <p:clrMapOvr>
     <a:masterClrMapping/>
   </p:clrMapOvr>
+  <mc:AlternateContent xmlns:mc="http://schemas.openxmlformats.org/markup-compatibility/2006" xmlns:p14="http://schemas.microsoft.com/office/powerpoint/2010/main">
+    <mc:Choice Requires="p14">
+      <p:transition spd="slow" p14:dur="2000">
+        <p:cut/>
+      </p:transition>
+    </mc:Choice>
+    <mc:Fallback xmlns="">
+      <p:transition spd="slow">
+        <p:cut/>
+      </p:transition>
+    </mc:Fallback>
+  </mc:AlternateContent>
 </p:sld>
 </file>
 
@@ -14363,6 +14773,18 @@
   <p:clrMapOvr>
     <a:masterClrMapping/>
   </p:clrMapOvr>
+  <mc:AlternateContent xmlns:mc="http://schemas.openxmlformats.org/markup-compatibility/2006" xmlns:p14="http://schemas.microsoft.com/office/powerpoint/2010/main">
+    <mc:Choice Requires="p14">
+      <p:transition spd="slow" p14:dur="2000">
+        <p:cut/>
+      </p:transition>
+    </mc:Choice>
+    <mc:Fallback xmlns="">
+      <p:transition spd="slow">
+        <p:cut/>
+      </p:transition>
+    </mc:Fallback>
+  </mc:AlternateContent>
 </p:sld>
 </file>
 
@@ -15249,6 +15671,18 @@
   <p:clrMapOvr>
     <a:masterClrMapping/>
   </p:clrMapOvr>
+  <mc:AlternateContent xmlns:mc="http://schemas.openxmlformats.org/markup-compatibility/2006" xmlns:p14="http://schemas.microsoft.com/office/powerpoint/2010/main">
+    <mc:Choice Requires="p14">
+      <p:transition spd="slow" p14:dur="2000">
+        <p:cut/>
+      </p:transition>
+    </mc:Choice>
+    <mc:Fallback xmlns="">
+      <p:transition spd="slow">
+        <p:cut/>
+      </p:transition>
+    </mc:Fallback>
+  </mc:AlternateContent>
 </p:sld>
 </file>
 
@@ -16120,6 +16554,18 @@
   <p:clrMapOvr>
     <a:masterClrMapping/>
   </p:clrMapOvr>
+  <mc:AlternateContent xmlns:mc="http://schemas.openxmlformats.org/markup-compatibility/2006" xmlns:p14="http://schemas.microsoft.com/office/powerpoint/2010/main">
+    <mc:Choice Requires="p14">
+      <p:transition spd="slow" p14:dur="2000">
+        <p:cut/>
+      </p:transition>
+    </mc:Choice>
+    <mc:Fallback xmlns="">
+      <p:transition spd="slow">
+        <p:cut/>
+      </p:transition>
+    </mc:Fallback>
+  </mc:AlternateContent>
 </p:sld>
 </file>
 
@@ -16767,6 +17213,18 @@
   <p:clrMapOvr>
     <a:masterClrMapping/>
   </p:clrMapOvr>
+  <mc:AlternateContent xmlns:mc="http://schemas.openxmlformats.org/markup-compatibility/2006" xmlns:p14="http://schemas.microsoft.com/office/powerpoint/2010/main">
+    <mc:Choice Requires="p14">
+      <p:transition spd="slow" p14:dur="2000">
+        <p:cut/>
+      </p:transition>
+    </mc:Choice>
+    <mc:Fallback xmlns="">
+      <p:transition spd="slow">
+        <p:cut/>
+      </p:transition>
+    </mc:Fallback>
+  </mc:AlternateContent>
 </p:sld>
 </file>
 
@@ -17386,6 +17844,18 @@
   <p:clrMapOvr>
     <a:masterClrMapping/>
   </p:clrMapOvr>
+  <mc:AlternateContent xmlns:mc="http://schemas.openxmlformats.org/markup-compatibility/2006" xmlns:p14="http://schemas.microsoft.com/office/powerpoint/2010/main">
+    <mc:Choice Requires="p14">
+      <p:transition spd="slow" p14:dur="2000">
+        <p:cut/>
+      </p:transition>
+    </mc:Choice>
+    <mc:Fallback xmlns="">
+      <p:transition spd="slow">
+        <p:cut/>
+      </p:transition>
+    </mc:Fallback>
+  </mc:AlternateContent>
 </p:sld>
 </file>
 
@@ -17630,6 +18100,18 @@
   <p:clrMapOvr>
     <a:masterClrMapping/>
   </p:clrMapOvr>
+  <mc:AlternateContent xmlns:mc="http://schemas.openxmlformats.org/markup-compatibility/2006" xmlns:p14="http://schemas.microsoft.com/office/powerpoint/2010/main">
+    <mc:Choice Requires="p14">
+      <p:transition spd="slow" p14:dur="2000">
+        <p:cut/>
+      </p:transition>
+    </mc:Choice>
+    <mc:Fallback xmlns="">
+      <p:transition spd="slow">
+        <p:cut/>
+      </p:transition>
+    </mc:Fallback>
+  </mc:AlternateContent>
 </p:sld>
 </file>
 
@@ -18136,6 +18618,18 @@
   <p:clrMapOvr>
     <a:masterClrMapping/>
   </p:clrMapOvr>
+  <mc:AlternateContent xmlns:mc="http://schemas.openxmlformats.org/markup-compatibility/2006" xmlns:p14="http://schemas.microsoft.com/office/powerpoint/2010/main">
+    <mc:Choice Requires="p14">
+      <p:transition spd="slow" p14:dur="2000">
+        <p:cut/>
+      </p:transition>
+    </mc:Choice>
+    <mc:Fallback xmlns="">
+      <p:transition spd="slow">
+        <p:cut/>
+      </p:transition>
+    </mc:Fallback>
+  </mc:AlternateContent>
 </p:sld>
 </file>
 
@@ -18831,6 +19325,18 @@
   <p:clrMapOvr>
     <a:masterClrMapping/>
   </p:clrMapOvr>
+  <mc:AlternateContent xmlns:mc="http://schemas.openxmlformats.org/markup-compatibility/2006" xmlns:p14="http://schemas.microsoft.com/office/powerpoint/2010/main">
+    <mc:Choice Requires="p14">
+      <p:transition spd="slow" p14:dur="2000">
+        <p:cut/>
+      </p:transition>
+    </mc:Choice>
+    <mc:Fallback xmlns="">
+      <p:transition spd="slow">
+        <p:cut/>
+      </p:transition>
+    </mc:Fallback>
+  </mc:AlternateContent>
 </p:sld>
 </file>
 
@@ -19075,6 +19581,18 @@
   <p:clrMapOvr>
     <a:masterClrMapping/>
   </p:clrMapOvr>
+  <mc:AlternateContent xmlns:mc="http://schemas.openxmlformats.org/markup-compatibility/2006" xmlns:p14="http://schemas.microsoft.com/office/powerpoint/2010/main">
+    <mc:Choice Requires="p14">
+      <p:transition spd="slow" p14:dur="2000">
+        <p:cut/>
+      </p:transition>
+    </mc:Choice>
+    <mc:Fallback xmlns="">
+      <p:transition spd="slow">
+        <p:cut/>
+      </p:transition>
+    </mc:Fallback>
+  </mc:AlternateContent>
 </p:sld>
 </file>
 
@@ -19852,6 +20370,18 @@
   <p:clrMapOvr>
     <a:masterClrMapping/>
   </p:clrMapOvr>
+  <mc:AlternateContent xmlns:mc="http://schemas.openxmlformats.org/markup-compatibility/2006" xmlns:p14="http://schemas.microsoft.com/office/powerpoint/2010/main">
+    <mc:Choice Requires="p14">
+      <p:transition spd="slow" p14:dur="2000">
+        <p:cut/>
+      </p:transition>
+    </mc:Choice>
+    <mc:Fallback xmlns="">
+      <p:transition spd="slow">
+        <p:cut/>
+      </p:transition>
+    </mc:Fallback>
+  </mc:AlternateContent>
 </p:sld>
 </file>
 
@@ -20420,6 +20950,18 @@
   <p:clrMapOvr>
     <a:masterClrMapping/>
   </p:clrMapOvr>
+  <mc:AlternateContent xmlns:mc="http://schemas.openxmlformats.org/markup-compatibility/2006" xmlns:p14="http://schemas.microsoft.com/office/powerpoint/2010/main">
+    <mc:Choice Requires="p14">
+      <p:transition spd="slow" p14:dur="2000">
+        <p:cut/>
+      </p:transition>
+    </mc:Choice>
+    <mc:Fallback xmlns="">
+      <p:transition spd="slow">
+        <p:cut/>
+      </p:transition>
+    </mc:Fallback>
+  </mc:AlternateContent>
 </p:sld>
 </file>
 
@@ -21056,6 +21598,18 @@
   <p:clrMapOvr>
     <a:masterClrMapping/>
   </p:clrMapOvr>
+  <mc:AlternateContent xmlns:mc="http://schemas.openxmlformats.org/markup-compatibility/2006" xmlns:p14="http://schemas.microsoft.com/office/powerpoint/2010/main">
+    <mc:Choice Requires="p14">
+      <p:transition spd="slow" p14:dur="2000">
+        <p:cut/>
+      </p:transition>
+    </mc:Choice>
+    <mc:Fallback xmlns="">
+      <p:transition spd="slow">
+        <p:cut/>
+      </p:transition>
+    </mc:Fallback>
+  </mc:AlternateContent>
 </p:sld>
 </file>
 
@@ -21300,6 +21854,18 @@
   <p:clrMapOvr>
     <a:masterClrMapping/>
   </p:clrMapOvr>
+  <mc:AlternateContent xmlns:mc="http://schemas.openxmlformats.org/markup-compatibility/2006" xmlns:p14="http://schemas.microsoft.com/office/powerpoint/2010/main">
+    <mc:Choice Requires="p14">
+      <p:transition spd="slow" p14:dur="2000">
+        <p:cut/>
+      </p:transition>
+    </mc:Choice>
+    <mc:Fallback xmlns="">
+      <p:transition spd="slow">
+        <p:cut/>
+      </p:transition>
+    </mc:Fallback>
+  </mc:AlternateContent>
 </p:sld>
 </file>
 
@@ -21822,6 +22388,18 @@
   <p:clrMapOvr>
     <a:masterClrMapping/>
   </p:clrMapOvr>
+  <mc:AlternateContent xmlns:mc="http://schemas.openxmlformats.org/markup-compatibility/2006" xmlns:p14="http://schemas.microsoft.com/office/powerpoint/2010/main">
+    <mc:Choice Requires="p14">
+      <p:transition spd="slow" p14:dur="2000">
+        <p:cut/>
+      </p:transition>
+    </mc:Choice>
+    <mc:Fallback xmlns="">
+      <p:transition spd="slow">
+        <p:cut/>
+      </p:transition>
+    </mc:Fallback>
+  </mc:AlternateContent>
 </p:sld>
 </file>
 
@@ -22549,6 +23127,18 @@
   <p:clrMapOvr>
     <a:masterClrMapping/>
   </p:clrMapOvr>
+  <mc:AlternateContent xmlns:mc="http://schemas.openxmlformats.org/markup-compatibility/2006" xmlns:p14="http://schemas.microsoft.com/office/powerpoint/2010/main">
+    <mc:Choice Requires="p14">
+      <p:transition spd="slow" p14:dur="2000">
+        <p:cut/>
+      </p:transition>
+    </mc:Choice>
+    <mc:Fallback xmlns="">
+      <p:transition spd="slow">
+        <p:cut/>
+      </p:transition>
+    </mc:Fallback>
+  </mc:AlternateContent>
 </p:sld>
 </file>
 
@@ -23328,6 +23918,18 @@
   <p:clrMapOvr>
     <a:masterClrMapping/>
   </p:clrMapOvr>
+  <mc:AlternateContent xmlns:mc="http://schemas.openxmlformats.org/markup-compatibility/2006" xmlns:p14="http://schemas.microsoft.com/office/powerpoint/2010/main">
+    <mc:Choice Requires="p14">
+      <p:transition spd="slow" p14:dur="2000">
+        <p:cut/>
+      </p:transition>
+    </mc:Choice>
+    <mc:Fallback xmlns="">
+      <p:transition spd="slow">
+        <p:cut/>
+      </p:transition>
+    </mc:Fallback>
+  </mc:AlternateContent>
 </p:sld>
 </file>
 
@@ -24271,6 +24873,18 @@
   <p:clrMapOvr>
     <a:masterClrMapping/>
   </p:clrMapOvr>
+  <mc:AlternateContent xmlns:mc="http://schemas.openxmlformats.org/markup-compatibility/2006" xmlns:p14="http://schemas.microsoft.com/office/powerpoint/2010/main">
+    <mc:Choice Requires="p14">
+      <p:transition spd="slow" p14:dur="2000">
+        <p:cut/>
+      </p:transition>
+    </mc:Choice>
+    <mc:Fallback xmlns="">
+      <p:transition spd="slow">
+        <p:cut/>
+      </p:transition>
+    </mc:Fallback>
+  </mc:AlternateContent>
 </p:sld>
 </file>
 
@@ -24782,6 +25396,18 @@
   <p:clrMapOvr>
     <a:masterClrMapping/>
   </p:clrMapOvr>
+  <mc:AlternateContent xmlns:mc="http://schemas.openxmlformats.org/markup-compatibility/2006" xmlns:p14="http://schemas.microsoft.com/office/powerpoint/2010/main">
+    <mc:Choice Requires="p14">
+      <p:transition spd="slow" p14:dur="2000">
+        <p:cut/>
+      </p:transition>
+    </mc:Choice>
+    <mc:Fallback xmlns="">
+      <p:transition spd="slow">
+        <p:cut/>
+      </p:transition>
+    </mc:Fallback>
+  </mc:AlternateContent>
 </p:sld>
 </file>
 
@@ -25269,6 +25895,18 @@
   <p:clrMapOvr>
     <a:masterClrMapping/>
   </p:clrMapOvr>
+  <mc:AlternateContent xmlns:mc="http://schemas.openxmlformats.org/markup-compatibility/2006" xmlns:p14="http://schemas.microsoft.com/office/powerpoint/2010/main">
+    <mc:Choice Requires="p14">
+      <p:transition spd="slow" p14:dur="2000">
+        <p:cut/>
+      </p:transition>
+    </mc:Choice>
+    <mc:Fallback xmlns="">
+      <p:transition spd="slow">
+        <p:cut/>
+      </p:transition>
+    </mc:Fallback>
+  </mc:AlternateContent>
 </p:sld>
 </file>
 
@@ -25872,6 +26510,18 @@
   <p:clrMapOvr>
     <a:masterClrMapping/>
   </p:clrMapOvr>
+  <mc:AlternateContent xmlns:mc="http://schemas.openxmlformats.org/markup-compatibility/2006" xmlns:p14="http://schemas.microsoft.com/office/powerpoint/2010/main">
+    <mc:Choice Requires="p14">
+      <p:transition spd="slow" p14:dur="2000">
+        <p:cut/>
+      </p:transition>
+    </mc:Choice>
+    <mc:Fallback xmlns="">
+      <p:transition spd="slow">
+        <p:cut/>
+      </p:transition>
+    </mc:Fallback>
+  </mc:AlternateContent>
 </p:sld>
 </file>
 
@@ -26116,6 +26766,18 @@
   <p:clrMapOvr>
     <a:masterClrMapping/>
   </p:clrMapOvr>
+  <mc:AlternateContent xmlns:mc="http://schemas.openxmlformats.org/markup-compatibility/2006" xmlns:p14="http://schemas.microsoft.com/office/powerpoint/2010/main">
+    <mc:Choice Requires="p14">
+      <p:transition spd="slow" p14:dur="2000">
+        <p:cut/>
+      </p:transition>
+    </mc:Choice>
+    <mc:Fallback xmlns="">
+      <p:transition spd="slow">
+        <p:cut/>
+      </p:transition>
+    </mc:Fallback>
+  </mc:AlternateContent>
 </p:sld>
 </file>
 
@@ -26926,6 +27588,18 @@
   <p:clrMapOvr>
     <a:masterClrMapping/>
   </p:clrMapOvr>
+  <mc:AlternateContent xmlns:mc="http://schemas.openxmlformats.org/markup-compatibility/2006" xmlns:p14="http://schemas.microsoft.com/office/powerpoint/2010/main">
+    <mc:Choice Requires="p14">
+      <p:transition spd="slow" p14:dur="2000">
+        <p:cut/>
+      </p:transition>
+    </mc:Choice>
+    <mc:Fallback xmlns="">
+      <p:transition spd="slow">
+        <p:cut/>
+      </p:transition>
+    </mc:Fallback>
+  </mc:AlternateContent>
 </p:sld>
 </file>
 
@@ -27896,6 +28570,18 @@
   <p:clrMapOvr>
     <a:masterClrMapping/>
   </p:clrMapOvr>
+  <mc:AlternateContent xmlns:mc="http://schemas.openxmlformats.org/markup-compatibility/2006" xmlns:p14="http://schemas.microsoft.com/office/powerpoint/2010/main">
+    <mc:Choice Requires="p14">
+      <p:transition spd="slow" p14:dur="2000">
+        <p:cut/>
+      </p:transition>
+    </mc:Choice>
+    <mc:Fallback xmlns="">
+      <p:transition spd="slow">
+        <p:cut/>
+      </p:transition>
+    </mc:Fallback>
+  </mc:AlternateContent>
 </p:sld>
 </file>
 
@@ -28140,6 +28826,18 @@
   <p:clrMapOvr>
     <a:masterClrMapping/>
   </p:clrMapOvr>
+  <mc:AlternateContent xmlns:mc="http://schemas.openxmlformats.org/markup-compatibility/2006" xmlns:p14="http://schemas.microsoft.com/office/powerpoint/2010/main">
+    <mc:Choice Requires="p14">
+      <p:transition spd="slow" p14:dur="2000">
+        <p:cut/>
+      </p:transition>
+    </mc:Choice>
+    <mc:Fallback xmlns="">
+      <p:transition spd="slow">
+        <p:cut/>
+      </p:transition>
+    </mc:Fallback>
+  </mc:AlternateContent>
 </p:sld>
 </file>
 
@@ -28465,7 +29163,7 @@
 
 <file path=ppt/webextensions/taskpanes.xml><?xml version="1.0" encoding="utf-8"?>
 <wetp:taskpanes xmlns:wetp="http://schemas.microsoft.com/office/webextensions/taskpanes/2010/11">
-  <wetp:taskpane dockstate="right" visibility="0" width="525" row="0">
+  <wetp:taskpane dockstate="right" visibility="0" width="437" row="0">
     <wetp:webextensionref xmlns:r="http://schemas.openxmlformats.org/officeDocument/2006/relationships" r:id="rId1"/>
   </wetp:taskpane>
 </wetp:taskpanes>

</xml_diff>